<commit_message>
on commence a architecturer tout ça sur plusieurs cores
</commit_message>
<xml_diff>
--- a/docs/architecture.pptx
+++ b/docs/architecture.pptx
@@ -6,9 +6,10 @@
   </p:sldMasterIdLst>
   <p:sldIdLst>
     <p:sldId id="260" r:id="rId2"/>
-    <p:sldId id="261" r:id="rId3"/>
-    <p:sldId id="262" r:id="rId4"/>
-    <p:sldId id="263" r:id="rId5"/>
+    <p:sldId id="264" r:id="rId3"/>
+    <p:sldId id="261" r:id="rId4"/>
+    <p:sldId id="262" r:id="rId5"/>
+    <p:sldId id="263" r:id="rId6"/>
   </p:sldIdLst>
   <p:sldSz cx="12192000" cy="6858000"/>
   <p:notesSz cx="6858000" cy="9144000"/>
@@ -273,7 +274,7 @@
           <a:p>
             <a:fld id="{CEA30D6E-8026-458F-AE61-B945DF15BAB5}" type="datetimeFigureOut">
               <a:rPr lang="fr-FR" smtClean="0"/>
-              <a:t>23/11/2025</a:t>
+              <a:t>28/11/2025</a:t>
             </a:fld>
             <a:endParaRPr lang="fr-FR"/>
           </a:p>
@@ -471,7 +472,7 @@
           <a:p>
             <a:fld id="{CEA30D6E-8026-458F-AE61-B945DF15BAB5}" type="datetimeFigureOut">
               <a:rPr lang="fr-FR" smtClean="0"/>
-              <a:t>23/11/2025</a:t>
+              <a:t>28/11/2025</a:t>
             </a:fld>
             <a:endParaRPr lang="fr-FR"/>
           </a:p>
@@ -679,7 +680,7 @@
           <a:p>
             <a:fld id="{CEA30D6E-8026-458F-AE61-B945DF15BAB5}" type="datetimeFigureOut">
               <a:rPr lang="fr-FR" smtClean="0"/>
-              <a:t>23/11/2025</a:t>
+              <a:t>28/11/2025</a:t>
             </a:fld>
             <a:endParaRPr lang="fr-FR"/>
           </a:p>
@@ -877,7 +878,7 @@
           <a:p>
             <a:fld id="{CEA30D6E-8026-458F-AE61-B945DF15BAB5}" type="datetimeFigureOut">
               <a:rPr lang="fr-FR" smtClean="0"/>
-              <a:t>23/11/2025</a:t>
+              <a:t>28/11/2025</a:t>
             </a:fld>
             <a:endParaRPr lang="fr-FR"/>
           </a:p>
@@ -1152,7 +1153,7 @@
           <a:p>
             <a:fld id="{CEA30D6E-8026-458F-AE61-B945DF15BAB5}" type="datetimeFigureOut">
               <a:rPr lang="fr-FR" smtClean="0"/>
-              <a:t>23/11/2025</a:t>
+              <a:t>28/11/2025</a:t>
             </a:fld>
             <a:endParaRPr lang="fr-FR"/>
           </a:p>
@@ -1417,7 +1418,7 @@
           <a:p>
             <a:fld id="{CEA30D6E-8026-458F-AE61-B945DF15BAB5}" type="datetimeFigureOut">
               <a:rPr lang="fr-FR" smtClean="0"/>
-              <a:t>23/11/2025</a:t>
+              <a:t>28/11/2025</a:t>
             </a:fld>
             <a:endParaRPr lang="fr-FR"/>
           </a:p>
@@ -1829,7 +1830,7 @@
           <a:p>
             <a:fld id="{CEA30D6E-8026-458F-AE61-B945DF15BAB5}" type="datetimeFigureOut">
               <a:rPr lang="fr-FR" smtClean="0"/>
-              <a:t>23/11/2025</a:t>
+              <a:t>28/11/2025</a:t>
             </a:fld>
             <a:endParaRPr lang="fr-FR"/>
           </a:p>
@@ -1970,7 +1971,7 @@
           <a:p>
             <a:fld id="{CEA30D6E-8026-458F-AE61-B945DF15BAB5}" type="datetimeFigureOut">
               <a:rPr lang="fr-FR" smtClean="0"/>
-              <a:t>23/11/2025</a:t>
+              <a:t>28/11/2025</a:t>
             </a:fld>
             <a:endParaRPr lang="fr-FR"/>
           </a:p>
@@ -2083,7 +2084,7 @@
           <a:p>
             <a:fld id="{CEA30D6E-8026-458F-AE61-B945DF15BAB5}" type="datetimeFigureOut">
               <a:rPr lang="fr-FR" smtClean="0"/>
-              <a:t>23/11/2025</a:t>
+              <a:t>28/11/2025</a:t>
             </a:fld>
             <a:endParaRPr lang="fr-FR"/>
           </a:p>
@@ -2394,7 +2395,7 @@
           <a:p>
             <a:fld id="{CEA30D6E-8026-458F-AE61-B945DF15BAB5}" type="datetimeFigureOut">
               <a:rPr lang="fr-FR" smtClean="0"/>
-              <a:t>23/11/2025</a:t>
+              <a:t>28/11/2025</a:t>
             </a:fld>
             <a:endParaRPr lang="fr-FR"/>
           </a:p>
@@ -2682,7 +2683,7 @@
           <a:p>
             <a:fld id="{CEA30D6E-8026-458F-AE61-B945DF15BAB5}" type="datetimeFigureOut">
               <a:rPr lang="fr-FR" smtClean="0"/>
-              <a:t>23/11/2025</a:t>
+              <a:t>28/11/2025</a:t>
             </a:fld>
             <a:endParaRPr lang="fr-FR"/>
           </a:p>
@@ -2923,7 +2924,7 @@
           <a:p>
             <a:fld id="{CEA30D6E-8026-458F-AE61-B945DF15BAB5}" type="datetimeFigureOut">
               <a:rPr lang="fr-FR" smtClean="0"/>
-              <a:t>23/11/2025</a:t>
+              <a:t>28/11/2025</a:t>
             </a:fld>
             <a:endParaRPr lang="fr-FR"/>
           </a:p>
@@ -3890,7 +3891,7 @@
           <a:lstStyle/>
           <a:p>
             <a:pPr algn="ctr"/>
-            <a:endParaRPr lang="fr-FR">
+            <a:endParaRPr lang="fr-FR" dirty="0">
               <a:solidFill>
                 <a:schemeClr val="tx1"/>
               </a:solidFill>
@@ -3941,7 +3942,7 @@
           <a:lstStyle/>
           <a:p>
             <a:pPr algn="ctr"/>
-            <a:endParaRPr lang="fr-FR">
+            <a:endParaRPr lang="fr-FR" dirty="0">
               <a:solidFill>
                 <a:schemeClr val="tx1"/>
               </a:solidFill>
@@ -4057,7 +4058,7 @@
           <a:lstStyle/>
           <a:p>
             <a:pPr algn="ctr"/>
-            <a:endParaRPr lang="fr-FR">
+            <a:endParaRPr lang="fr-FR" dirty="0">
               <a:solidFill>
                 <a:schemeClr val="tx1"/>
               </a:solidFill>
@@ -4528,7 +4529,7 @@
           <a:lstStyle/>
           <a:p>
             <a:pPr algn="ctr"/>
-            <a:endParaRPr lang="fr-FR">
+            <a:endParaRPr lang="fr-FR" dirty="0">
               <a:solidFill>
                 <a:schemeClr val="tx1"/>
               </a:solidFill>
@@ -4601,12 +4602,55 @@
           </a:p>
         </p:txBody>
       </p:sp>
-      <p:sp>
-        <p:nvSpPr>
-          <p:cNvPr id="23" name="Rectangle : coins arrondis 22">
-            <a:extLst>
-              <a:ext uri="{FF2B5EF4-FFF2-40B4-BE49-F238E27FC236}">
-                <a16:creationId xmlns:a16="http://schemas.microsoft.com/office/drawing/2014/main" id="{76A4345D-1C8D-0416-DD9B-75CF7154B5B1}"/>
+      <p:cxnSp>
+        <p:nvCxnSpPr>
+          <p:cNvPr id="9" name="Connecteur droit avec flèche 8">
+            <a:extLst>
+              <a:ext uri="{FF2B5EF4-FFF2-40B4-BE49-F238E27FC236}">
+                <a16:creationId xmlns:a16="http://schemas.microsoft.com/office/drawing/2014/main" id="{21D68426-51E3-F9C6-218C-A09DB11D384C}"/>
+              </a:ext>
+            </a:extLst>
+          </p:cNvPr>
+          <p:cNvCxnSpPr>
+            <a:cxnSpLocks/>
+            <a:stCxn id="58" idx="2"/>
+            <a:endCxn id="3" idx="0"/>
+          </p:cNvCxnSpPr>
+          <p:nvPr/>
+        </p:nvCxnSpPr>
+        <p:spPr>
+          <a:xfrm>
+            <a:off x="6442800" y="2981325"/>
+            <a:ext cx="0" cy="623635"/>
+          </a:xfrm>
+          <a:prstGeom prst="straightConnector1">
+            <a:avLst/>
+          </a:prstGeom>
+          <a:ln>
+            <a:tailEnd type="triangle"/>
+          </a:ln>
+        </p:spPr>
+        <p:style>
+          <a:lnRef idx="2">
+            <a:schemeClr val="dk1"/>
+          </a:lnRef>
+          <a:fillRef idx="0">
+            <a:schemeClr val="dk1"/>
+          </a:fillRef>
+          <a:effectRef idx="1">
+            <a:schemeClr val="dk1"/>
+          </a:effectRef>
+          <a:fontRef idx="minor">
+            <a:schemeClr val="tx1"/>
+          </a:fontRef>
+        </p:style>
+      </p:cxnSp>
+      <p:sp>
+        <p:nvSpPr>
+          <p:cNvPr id="19" name="Rectangle : coins arrondis 18">
+            <a:extLst>
+              <a:ext uri="{FF2B5EF4-FFF2-40B4-BE49-F238E27FC236}">
+                <a16:creationId xmlns:a16="http://schemas.microsoft.com/office/drawing/2014/main" id="{2AB85A98-32E3-6593-ACC1-B34750D1AC39}"/>
               </a:ext>
             </a:extLst>
           </p:cNvPr>
@@ -4615,8 +4659,8 @@
         </p:nvSpPr>
         <p:spPr>
           <a:xfrm>
-            <a:off x="8558658" y="3166572"/>
-            <a:ext cx="1119664" cy="256991"/>
+            <a:off x="3267075" y="4536428"/>
+            <a:ext cx="1316326" cy="540000"/>
           </a:xfrm>
           <a:prstGeom prst="roundRect">
             <a:avLst/>
@@ -4652,42 +4696,54 @@
           </a:fontRef>
         </p:style>
         <p:txBody>
-          <a:bodyPr rtlCol="0" anchor="ctr"/>
-          <a:lstStyle/>
-          <a:p>
+          <a:bodyPr rtlCol="0" anchor="t"/>
+          <a:lstStyle/>
+          <a:p>
+            <a:pPr algn="ctr"/>
+            <a:r>
+              <a:rPr lang="fr-FR" sz="1000" b="1" dirty="0">
+                <a:solidFill>
+                  <a:schemeClr val="tx1"/>
+                </a:solidFill>
+              </a:rPr>
+              <a:t>TASK </a:t>
+            </a:r>
+          </a:p>
+          <a:p>
+            <a:pPr algn="ctr"/>
             <a:r>
               <a:rPr lang="fr-FR" sz="1000" dirty="0">
                 <a:solidFill>
                   <a:schemeClr val="tx1"/>
                 </a:solidFill>
               </a:rPr>
-              <a:t>Image détordue</a:t>
+              <a:t>Record vidéo</a:t>
             </a:r>
           </a:p>
         </p:txBody>
       </p:sp>
       <p:cxnSp>
         <p:nvCxnSpPr>
-          <p:cNvPr id="9" name="Connecteur droit avec flèche 8">
-            <a:extLst>
-              <a:ext uri="{FF2B5EF4-FFF2-40B4-BE49-F238E27FC236}">
-                <a16:creationId xmlns:a16="http://schemas.microsoft.com/office/drawing/2014/main" id="{21D68426-51E3-F9C6-218C-A09DB11D384C}"/>
+          <p:cNvPr id="26" name="Connecteur : en angle 25">
+            <a:extLst>
+              <a:ext uri="{FF2B5EF4-FFF2-40B4-BE49-F238E27FC236}">
+                <a16:creationId xmlns:a16="http://schemas.microsoft.com/office/drawing/2014/main" id="{BD4E4805-01E2-4408-5075-726F5878908E}"/>
               </a:ext>
             </a:extLst>
           </p:cNvPr>
           <p:cNvCxnSpPr>
             <a:cxnSpLocks/>
             <a:stCxn id="58" idx="2"/>
-            <a:endCxn id="3" idx="0"/>
+            <a:endCxn id="74" idx="0"/>
           </p:cNvCxnSpPr>
           <p:nvPr/>
         </p:nvCxnSpPr>
         <p:spPr>
-          <a:xfrm>
-            <a:off x="6442800" y="2981325"/>
-            <a:ext cx="0" cy="623635"/>
-          </a:xfrm>
-          <a:prstGeom prst="straightConnector1">
+          <a:xfrm rot="5400000">
+            <a:off x="4472658" y="1634817"/>
+            <a:ext cx="623635" cy="3316650"/>
+          </a:xfrm>
+          <a:prstGeom prst="bentConnector3">
             <a:avLst/>
           </a:prstGeom>
           <a:ln>
@@ -4711,10 +4767,47 @@
       </p:cxnSp>
       <p:sp>
         <p:nvSpPr>
-          <p:cNvPr id="19" name="Rectangle : coins arrondis 18">
-            <a:extLst>
-              <a:ext uri="{FF2B5EF4-FFF2-40B4-BE49-F238E27FC236}">
-                <a16:creationId xmlns:a16="http://schemas.microsoft.com/office/drawing/2014/main" id="{2AB85A98-32E3-6593-ACC1-B34750D1AC39}"/>
+          <p:cNvPr id="29" name="ZoneTexte 28">
+            <a:extLst>
+              <a:ext uri="{FF2B5EF4-FFF2-40B4-BE49-F238E27FC236}">
+                <a16:creationId xmlns:a16="http://schemas.microsoft.com/office/drawing/2014/main" id="{58CDE725-1D84-6219-A3B0-30CF0937AFFF}"/>
+              </a:ext>
+            </a:extLst>
+          </p:cNvPr>
+          <p:cNvSpPr txBox="1"/>
+          <p:nvPr/>
+        </p:nvSpPr>
+        <p:spPr>
+          <a:xfrm>
+            <a:off x="133350" y="93127"/>
+            <a:ext cx="3714750" cy="461665"/>
+          </a:xfrm>
+          <a:prstGeom prst="rect">
+            <a:avLst/>
+          </a:prstGeom>
+          <a:noFill/>
+        </p:spPr>
+        <p:txBody>
+          <a:bodyPr wrap="square" rtlCol="0">
+            <a:spAutoFit/>
+          </a:bodyPr>
+          <a:lstStyle/>
+          <a:p>
+            <a:r>
+              <a:rPr lang="fr-FR" sz="2400" dirty="0">
+                <a:latin typeface="Raleway" pitchFamily="2" charset="0"/>
+              </a:rPr>
+              <a:t>Architecture software</a:t>
+            </a:r>
+          </a:p>
+        </p:txBody>
+      </p:sp>
+      <p:sp>
+        <p:nvSpPr>
+          <p:cNvPr id="23" name="Rectangle : coins arrondis 22">
+            <a:extLst>
+              <a:ext uri="{FF2B5EF4-FFF2-40B4-BE49-F238E27FC236}">
+                <a16:creationId xmlns:a16="http://schemas.microsoft.com/office/drawing/2014/main" id="{76A4345D-1C8D-0416-DD9B-75CF7154B5B1}"/>
               </a:ext>
             </a:extLst>
           </p:cNvPr>
@@ -4723,8 +4816,8 @@
         </p:nvSpPr>
         <p:spPr>
           <a:xfrm>
-            <a:off x="3267075" y="4536428"/>
-            <a:ext cx="1316326" cy="540000"/>
+            <a:off x="3574846" y="3124544"/>
+            <a:ext cx="1119664" cy="256991"/>
           </a:xfrm>
           <a:prstGeom prst="roundRect">
             <a:avLst/>
@@ -4760,57 +4853,241 @@
           </a:fontRef>
         </p:style>
         <p:txBody>
-          <a:bodyPr rtlCol="0" anchor="t"/>
-          <a:lstStyle/>
-          <a:p>
-            <a:pPr algn="ctr"/>
-            <a:r>
-              <a:rPr lang="fr-FR" sz="1000" b="1" dirty="0">
-                <a:solidFill>
-                  <a:schemeClr val="tx1"/>
-                </a:solidFill>
-              </a:rPr>
-              <a:t>TASK </a:t>
-            </a:r>
-          </a:p>
-          <a:p>
-            <a:pPr algn="ctr"/>
+          <a:bodyPr rtlCol="0" anchor="ctr"/>
+          <a:lstStyle/>
+          <a:p>
             <a:r>
               <a:rPr lang="fr-FR" sz="1000" dirty="0">
                 <a:solidFill>
                   <a:schemeClr val="tx1"/>
                 </a:solidFill>
               </a:rPr>
-              <a:t>Record vidéo</a:t>
+              <a:t>Image détordue</a:t>
+            </a:r>
+          </a:p>
+        </p:txBody>
+      </p:sp>
+    </p:spTree>
+    <p:extLst>
+      <p:ext uri="{BB962C8B-B14F-4D97-AF65-F5344CB8AC3E}">
+        <p14:creationId xmlns:p14="http://schemas.microsoft.com/office/powerpoint/2010/main" val="1207860193"/>
+      </p:ext>
+    </p:extLst>
+  </p:cSld>
+  <p:clrMapOvr>
+    <a:masterClrMapping/>
+  </p:clrMapOvr>
+</p:sld>
+</file>
+
+<file path=ppt/slides/slide2.xml><?xml version="1.0" encoding="utf-8"?>
+<p:sld xmlns:a="http://schemas.openxmlformats.org/drawingml/2006/main" xmlns:r="http://schemas.openxmlformats.org/officeDocument/2006/relationships" xmlns:p="http://schemas.openxmlformats.org/presentationml/2006/main">
+  <p:cSld>
+    <p:spTree>
+      <p:nvGrpSpPr>
+        <p:cNvPr id="1" name="">
+          <a:extLst>
+            <a:ext uri="{FF2B5EF4-FFF2-40B4-BE49-F238E27FC236}">
+              <a16:creationId xmlns:a16="http://schemas.microsoft.com/office/drawing/2014/main" id="{3E3C08CC-1AC1-3377-B415-7DAB6105A995}"/>
+            </a:ext>
+          </a:extLst>
+        </p:cNvPr>
+        <p:cNvGrpSpPr/>
+        <p:nvPr/>
+      </p:nvGrpSpPr>
+      <p:grpSpPr>
+        <a:xfrm>
+          <a:off x="0" y="0"/>
+          <a:ext cx="0" cy="0"/>
+          <a:chOff x="0" y="0"/>
+          <a:chExt cx="0" cy="0"/>
+        </a:xfrm>
+      </p:grpSpPr>
+      <p:sp>
+        <p:nvSpPr>
+          <p:cNvPr id="3" name="Rectangle : coins arrondis 2">
+            <a:extLst>
+              <a:ext uri="{FF2B5EF4-FFF2-40B4-BE49-F238E27FC236}">
+                <a16:creationId xmlns:a16="http://schemas.microsoft.com/office/drawing/2014/main" id="{32D61BB0-C7E8-E478-2F23-92319AF05ACD}"/>
+              </a:ext>
+            </a:extLst>
+          </p:cNvPr>
+          <p:cNvSpPr/>
+          <p:nvPr/>
+        </p:nvSpPr>
+        <p:spPr>
+          <a:xfrm>
+            <a:off x="660113" y="2170597"/>
+            <a:ext cx="1983650" cy="338390"/>
+          </a:xfrm>
+          <a:prstGeom prst="roundRect">
+            <a:avLst>
+              <a:gd name="adj" fmla="val 10474"/>
+            </a:avLst>
+          </a:prstGeom>
+          <a:noFill/>
+          <a:ln w="12700">
+            <a:solidFill>
+              <a:schemeClr val="tx1"/>
+            </a:solidFill>
+          </a:ln>
+          <a:effectLst/>
+        </p:spPr>
+        <p:style>
+          <a:lnRef idx="2">
+            <a:schemeClr val="accent1">
+              <a:shade val="15000"/>
+            </a:schemeClr>
+          </a:lnRef>
+          <a:fillRef idx="1">
+            <a:schemeClr val="accent1"/>
+          </a:fillRef>
+          <a:effectRef idx="0">
+            <a:schemeClr val="accent1"/>
+          </a:effectRef>
+          <a:fontRef idx="minor">
+            <a:schemeClr val="lt1"/>
+          </a:fontRef>
+        </p:style>
+        <p:txBody>
+          <a:bodyPr rtlCol="0" anchor="ctr"/>
+          <a:lstStyle/>
+          <a:p>
+            <a:pPr algn="ctr"/>
+            <a:r>
+              <a:rPr lang="fr-FR" sz="1000" dirty="0">
+                <a:solidFill>
+                  <a:schemeClr val="tx1"/>
+                </a:solidFill>
+              </a:rPr>
+              <a:t>Conversion en noir et blanc</a:t>
+            </a:r>
+          </a:p>
+        </p:txBody>
+      </p:sp>
+      <p:sp>
+        <p:nvSpPr>
+          <p:cNvPr id="2" name="ZoneTexte 1">
+            <a:extLst>
+              <a:ext uri="{FF2B5EF4-FFF2-40B4-BE49-F238E27FC236}">
+                <a16:creationId xmlns:a16="http://schemas.microsoft.com/office/drawing/2014/main" id="{8680B6DD-31A5-BE5F-618B-5047CE152459}"/>
+              </a:ext>
+            </a:extLst>
+          </p:cNvPr>
+          <p:cNvSpPr txBox="1"/>
+          <p:nvPr/>
+        </p:nvSpPr>
+        <p:spPr>
+          <a:xfrm>
+            <a:off x="133350" y="93127"/>
+            <a:ext cx="3714750" cy="461665"/>
+          </a:xfrm>
+          <a:prstGeom prst="rect">
+            <a:avLst/>
+          </a:prstGeom>
+          <a:noFill/>
+        </p:spPr>
+        <p:txBody>
+          <a:bodyPr wrap="square" rtlCol="0">
+            <a:spAutoFit/>
+          </a:bodyPr>
+          <a:lstStyle/>
+          <a:p>
+            <a:r>
+              <a:rPr lang="fr-FR" sz="2400" dirty="0">
+                <a:latin typeface="Raleway" pitchFamily="2" charset="0"/>
+              </a:rPr>
+              <a:t>Traitement de l’image</a:t>
+            </a:r>
+          </a:p>
+        </p:txBody>
+      </p:sp>
+      <p:sp>
+        <p:nvSpPr>
+          <p:cNvPr id="5" name="Rectangle : coins arrondis 4">
+            <a:extLst>
+              <a:ext uri="{FF2B5EF4-FFF2-40B4-BE49-F238E27FC236}">
+                <a16:creationId xmlns:a16="http://schemas.microsoft.com/office/drawing/2014/main" id="{3549BABE-D9E3-00A2-6F4F-A20499C03336}"/>
+              </a:ext>
+            </a:extLst>
+          </p:cNvPr>
+          <p:cNvSpPr/>
+          <p:nvPr/>
+        </p:nvSpPr>
+        <p:spPr>
+          <a:xfrm>
+            <a:off x="660113" y="2925357"/>
+            <a:ext cx="1983650" cy="338390"/>
+          </a:xfrm>
+          <a:prstGeom prst="roundRect">
+            <a:avLst>
+              <a:gd name="adj" fmla="val 10474"/>
+            </a:avLst>
+          </a:prstGeom>
+          <a:noFill/>
+          <a:ln w="12700">
+            <a:solidFill>
+              <a:schemeClr val="tx1"/>
+            </a:solidFill>
+          </a:ln>
+          <a:effectLst/>
+        </p:spPr>
+        <p:style>
+          <a:lnRef idx="2">
+            <a:schemeClr val="accent1">
+              <a:shade val="15000"/>
+            </a:schemeClr>
+          </a:lnRef>
+          <a:fillRef idx="1">
+            <a:schemeClr val="accent1"/>
+          </a:fillRef>
+          <a:effectRef idx="0">
+            <a:schemeClr val="accent1"/>
+          </a:effectRef>
+          <a:fontRef idx="minor">
+            <a:schemeClr val="lt1"/>
+          </a:fontRef>
+        </p:style>
+        <p:txBody>
+          <a:bodyPr rtlCol="0" anchor="ctr"/>
+          <a:lstStyle/>
+          <a:p>
+            <a:pPr algn="ctr"/>
+            <a:r>
+              <a:rPr lang="fr-FR" sz="1000" dirty="0">
+                <a:solidFill>
+                  <a:schemeClr val="tx1"/>
+                </a:solidFill>
+              </a:rPr>
+              <a:t>Filtre coupe bande gris</a:t>
             </a:r>
           </a:p>
         </p:txBody>
       </p:sp>
       <p:cxnSp>
         <p:nvCxnSpPr>
-          <p:cNvPr id="26" name="Connecteur : en angle 25">
-            <a:extLst>
-              <a:ext uri="{FF2B5EF4-FFF2-40B4-BE49-F238E27FC236}">
-                <a16:creationId xmlns:a16="http://schemas.microsoft.com/office/drawing/2014/main" id="{BD4E4805-01E2-4408-5075-726F5878908E}"/>
+          <p:cNvPr id="7" name="Connecteur droit avec flèche 6">
+            <a:extLst>
+              <a:ext uri="{FF2B5EF4-FFF2-40B4-BE49-F238E27FC236}">
+                <a16:creationId xmlns:a16="http://schemas.microsoft.com/office/drawing/2014/main" id="{653F530B-E305-ED94-99FF-1720028CCA32}"/>
               </a:ext>
             </a:extLst>
           </p:cNvPr>
           <p:cNvCxnSpPr>
-            <a:cxnSpLocks/>
-            <a:stCxn id="58" idx="2"/>
-            <a:endCxn id="74" idx="0"/>
+            <a:stCxn id="3" idx="2"/>
+            <a:endCxn id="5" idx="0"/>
           </p:cNvCxnSpPr>
           <p:nvPr/>
         </p:nvCxnSpPr>
         <p:spPr>
-          <a:xfrm rot="5400000">
-            <a:off x="4472658" y="1634817"/>
-            <a:ext cx="623635" cy="3316650"/>
-          </a:xfrm>
-          <a:prstGeom prst="bentConnector3">
+          <a:xfrm>
+            <a:off x="1651938" y="2508987"/>
+            <a:ext cx="0" cy="416370"/>
+          </a:xfrm>
+          <a:prstGeom prst="straightConnector1">
             <a:avLst/>
           </a:prstGeom>
-          <a:ln>
+          <a:ln w="12700">
             <a:tailEnd type="triangle"/>
           </a:ln>
         </p:spPr>
@@ -4831,45 +5108,323 @@
       </p:cxnSp>
       <p:sp>
         <p:nvSpPr>
-          <p:cNvPr id="29" name="ZoneTexte 28">
-            <a:extLst>
-              <a:ext uri="{FF2B5EF4-FFF2-40B4-BE49-F238E27FC236}">
-                <a16:creationId xmlns:a16="http://schemas.microsoft.com/office/drawing/2014/main" id="{58CDE725-1D84-6219-A3B0-30CF0937AFFF}"/>
-              </a:ext>
-            </a:extLst>
-          </p:cNvPr>
-          <p:cNvSpPr txBox="1"/>
+          <p:cNvPr id="8" name="Rectangle : coins arrondis 7">
+            <a:extLst>
+              <a:ext uri="{FF2B5EF4-FFF2-40B4-BE49-F238E27FC236}">
+                <a16:creationId xmlns:a16="http://schemas.microsoft.com/office/drawing/2014/main" id="{0C552861-18B0-57D4-5007-4D1D1AC3D28E}"/>
+              </a:ext>
+            </a:extLst>
+          </p:cNvPr>
+          <p:cNvSpPr/>
           <p:nvPr/>
         </p:nvSpPr>
         <p:spPr>
           <a:xfrm>
-            <a:off x="133350" y="93127"/>
-            <a:ext cx="3714750" cy="461665"/>
-          </a:xfrm>
-          <a:prstGeom prst="rect">
+            <a:off x="660113" y="3680117"/>
+            <a:ext cx="1983650" cy="338390"/>
+          </a:xfrm>
+          <a:prstGeom prst="roundRect">
+            <a:avLst>
+              <a:gd name="adj" fmla="val 10474"/>
+            </a:avLst>
+          </a:prstGeom>
+          <a:noFill/>
+          <a:ln w="12700">
+            <a:solidFill>
+              <a:schemeClr val="tx1"/>
+            </a:solidFill>
+          </a:ln>
+          <a:effectLst/>
+        </p:spPr>
+        <p:style>
+          <a:lnRef idx="2">
+            <a:schemeClr val="accent1">
+              <a:shade val="15000"/>
+            </a:schemeClr>
+          </a:lnRef>
+          <a:fillRef idx="1">
+            <a:schemeClr val="accent1"/>
+          </a:fillRef>
+          <a:effectRef idx="0">
+            <a:schemeClr val="accent1"/>
+          </a:effectRef>
+          <a:fontRef idx="minor">
+            <a:schemeClr val="lt1"/>
+          </a:fontRef>
+        </p:style>
+        <p:txBody>
+          <a:bodyPr rtlCol="0" anchor="ctr"/>
+          <a:lstStyle/>
+          <a:p>
+            <a:pPr algn="ctr"/>
+            <a:r>
+              <a:rPr lang="fr-FR" sz="1000" dirty="0">
+                <a:solidFill>
+                  <a:schemeClr val="tx1"/>
+                </a:solidFill>
+              </a:rPr>
+              <a:t>Redressement de l’image</a:t>
+            </a:r>
+          </a:p>
+        </p:txBody>
+      </p:sp>
+      <p:cxnSp>
+        <p:nvCxnSpPr>
+          <p:cNvPr id="12" name="Connecteur droit avec flèche 11">
+            <a:extLst>
+              <a:ext uri="{FF2B5EF4-FFF2-40B4-BE49-F238E27FC236}">
+                <a16:creationId xmlns:a16="http://schemas.microsoft.com/office/drawing/2014/main" id="{B5AF0E33-7D31-6B41-3E42-833116863F08}"/>
+              </a:ext>
+            </a:extLst>
+          </p:cNvPr>
+          <p:cNvCxnSpPr>
+            <a:cxnSpLocks/>
+            <a:stCxn id="8" idx="2"/>
+            <a:endCxn id="18" idx="0"/>
+          </p:cNvCxnSpPr>
+          <p:nvPr/>
+        </p:nvCxnSpPr>
+        <p:spPr>
+          <a:xfrm>
+            <a:off x="1651938" y="4018507"/>
+            <a:ext cx="0" cy="416371"/>
+          </a:xfrm>
+          <a:prstGeom prst="straightConnector1">
             <a:avLst/>
           </a:prstGeom>
+          <a:ln w="12700">
+            <a:tailEnd type="triangle"/>
+          </a:ln>
+        </p:spPr>
+        <p:style>
+          <a:lnRef idx="2">
+            <a:schemeClr val="dk1"/>
+          </a:lnRef>
+          <a:fillRef idx="0">
+            <a:schemeClr val="dk1"/>
+          </a:fillRef>
+          <a:effectRef idx="1">
+            <a:schemeClr val="dk1"/>
+          </a:effectRef>
+          <a:fontRef idx="minor">
+            <a:schemeClr val="tx1"/>
+          </a:fontRef>
+        </p:style>
+      </p:cxnSp>
+      <p:sp>
+        <p:nvSpPr>
+          <p:cNvPr id="18" name="Rectangle : coins arrondis 17">
+            <a:extLst>
+              <a:ext uri="{FF2B5EF4-FFF2-40B4-BE49-F238E27FC236}">
+                <a16:creationId xmlns:a16="http://schemas.microsoft.com/office/drawing/2014/main" id="{60C38C58-5118-CFFD-163E-CDC3FC8B7AAA}"/>
+              </a:ext>
+            </a:extLst>
+          </p:cNvPr>
+          <p:cNvSpPr/>
+          <p:nvPr/>
+        </p:nvSpPr>
+        <p:spPr>
+          <a:xfrm>
+            <a:off x="660113" y="4434878"/>
+            <a:ext cx="1983650" cy="338390"/>
+          </a:xfrm>
+          <a:prstGeom prst="roundRect">
+            <a:avLst>
+              <a:gd name="adj" fmla="val 10474"/>
+            </a:avLst>
+          </a:prstGeom>
           <a:noFill/>
-        </p:spPr>
-        <p:txBody>
-          <a:bodyPr wrap="square" rtlCol="0">
-            <a:spAutoFit/>
-          </a:bodyPr>
-          <a:lstStyle/>
-          <a:p>
-            <a:r>
-              <a:rPr lang="fr-FR" sz="2400" dirty="0">
-                <a:latin typeface="Raleway" pitchFamily="2" charset="0"/>
+          <a:ln w="12700">
+            <a:solidFill>
+              <a:schemeClr val="tx1"/>
+            </a:solidFill>
+          </a:ln>
+          <a:effectLst/>
+        </p:spPr>
+        <p:style>
+          <a:lnRef idx="2">
+            <a:schemeClr val="accent1">
+              <a:shade val="15000"/>
+            </a:schemeClr>
+          </a:lnRef>
+          <a:fillRef idx="1">
+            <a:schemeClr val="accent1"/>
+          </a:fillRef>
+          <a:effectRef idx="0">
+            <a:schemeClr val="accent1"/>
+          </a:effectRef>
+          <a:fontRef idx="minor">
+            <a:schemeClr val="lt1"/>
+          </a:fontRef>
+        </p:style>
+        <p:txBody>
+          <a:bodyPr rtlCol="0" anchor="ctr"/>
+          <a:lstStyle/>
+          <a:p>
+            <a:pPr algn="ctr"/>
+            <a:r>
+              <a:rPr lang="fr-FR" sz="1000" dirty="0">
+                <a:solidFill>
+                  <a:schemeClr val="tx1"/>
+                </a:solidFill>
               </a:rPr>
-              <a:t>Architecture software</a:t>
-            </a:r>
-          </a:p>
-        </p:txBody>
-      </p:sp>
+              <a:t>Distorsion de l’image</a:t>
+            </a:r>
+          </a:p>
+        </p:txBody>
+      </p:sp>
+      <p:cxnSp>
+        <p:nvCxnSpPr>
+          <p:cNvPr id="20" name="Connecteur droit avec flèche 19">
+            <a:extLst>
+              <a:ext uri="{FF2B5EF4-FFF2-40B4-BE49-F238E27FC236}">
+                <a16:creationId xmlns:a16="http://schemas.microsoft.com/office/drawing/2014/main" id="{872E6A03-65D8-FD00-3D47-61A1C978A0B9}"/>
+              </a:ext>
+            </a:extLst>
+          </p:cNvPr>
+          <p:cNvCxnSpPr>
+            <a:cxnSpLocks/>
+            <a:stCxn id="5" idx="2"/>
+            <a:endCxn id="8" idx="0"/>
+          </p:cNvCxnSpPr>
+          <p:nvPr/>
+        </p:nvCxnSpPr>
+        <p:spPr>
+          <a:xfrm>
+            <a:off x="1651938" y="3263747"/>
+            <a:ext cx="0" cy="416370"/>
+          </a:xfrm>
+          <a:prstGeom prst="straightConnector1">
+            <a:avLst/>
+          </a:prstGeom>
+          <a:ln w="12700">
+            <a:tailEnd type="triangle"/>
+          </a:ln>
+        </p:spPr>
+        <p:style>
+          <a:lnRef idx="2">
+            <a:schemeClr val="dk1"/>
+          </a:lnRef>
+          <a:fillRef idx="0">
+            <a:schemeClr val="dk1"/>
+          </a:fillRef>
+          <a:effectRef idx="1">
+            <a:schemeClr val="dk1"/>
+          </a:effectRef>
+          <a:fontRef idx="minor">
+            <a:schemeClr val="tx1"/>
+          </a:fontRef>
+        </p:style>
+      </p:cxnSp>
+      <p:sp>
+        <p:nvSpPr>
+          <p:cNvPr id="28" name="Rectangle : coins arrondis 27">
+            <a:extLst>
+              <a:ext uri="{FF2B5EF4-FFF2-40B4-BE49-F238E27FC236}">
+                <a16:creationId xmlns:a16="http://schemas.microsoft.com/office/drawing/2014/main" id="{A5E986BA-1C23-D677-4A5C-A9075E991AF5}"/>
+              </a:ext>
+            </a:extLst>
+          </p:cNvPr>
+          <p:cNvSpPr/>
+          <p:nvPr/>
+        </p:nvSpPr>
+        <p:spPr>
+          <a:xfrm>
+            <a:off x="660113" y="1415837"/>
+            <a:ext cx="1983650" cy="338390"/>
+          </a:xfrm>
+          <a:prstGeom prst="roundRect">
+            <a:avLst>
+              <a:gd name="adj" fmla="val 10474"/>
+            </a:avLst>
+          </a:prstGeom>
+          <a:noFill/>
+          <a:ln w="12700">
+            <a:solidFill>
+              <a:schemeClr val="tx1"/>
+            </a:solidFill>
+          </a:ln>
+          <a:effectLst/>
+        </p:spPr>
+        <p:style>
+          <a:lnRef idx="2">
+            <a:schemeClr val="accent1">
+              <a:shade val="15000"/>
+            </a:schemeClr>
+          </a:lnRef>
+          <a:fillRef idx="1">
+            <a:schemeClr val="accent1"/>
+          </a:fillRef>
+          <a:effectRef idx="0">
+            <a:schemeClr val="accent1"/>
+          </a:effectRef>
+          <a:fontRef idx="minor">
+            <a:schemeClr val="lt1"/>
+          </a:fontRef>
+        </p:style>
+        <p:txBody>
+          <a:bodyPr rtlCol="0" anchor="ctr"/>
+          <a:lstStyle/>
+          <a:p>
+            <a:pPr algn="ctr"/>
+            <a:r>
+              <a:rPr lang="fr-FR" sz="1000" dirty="0">
+                <a:solidFill>
+                  <a:schemeClr val="tx1"/>
+                </a:solidFill>
+              </a:rPr>
+              <a:t>Correction lumière pourrie</a:t>
+            </a:r>
+          </a:p>
+        </p:txBody>
+      </p:sp>
+      <p:cxnSp>
+        <p:nvCxnSpPr>
+          <p:cNvPr id="30" name="Connecteur droit avec flèche 29">
+            <a:extLst>
+              <a:ext uri="{FF2B5EF4-FFF2-40B4-BE49-F238E27FC236}">
+                <a16:creationId xmlns:a16="http://schemas.microsoft.com/office/drawing/2014/main" id="{4E95FF95-E139-973B-A55B-A70A54243243}"/>
+              </a:ext>
+            </a:extLst>
+          </p:cNvPr>
+          <p:cNvCxnSpPr>
+            <a:cxnSpLocks/>
+            <a:stCxn id="28" idx="2"/>
+            <a:endCxn id="3" idx="0"/>
+          </p:cNvCxnSpPr>
+          <p:nvPr/>
+        </p:nvCxnSpPr>
+        <p:spPr>
+          <a:xfrm>
+            <a:off x="1651938" y="1754227"/>
+            <a:ext cx="0" cy="416370"/>
+          </a:xfrm>
+          <a:prstGeom prst="straightConnector1">
+            <a:avLst/>
+          </a:prstGeom>
+          <a:ln w="12700">
+            <a:tailEnd type="triangle"/>
+          </a:ln>
+        </p:spPr>
+        <p:style>
+          <a:lnRef idx="2">
+            <a:schemeClr val="dk1"/>
+          </a:lnRef>
+          <a:fillRef idx="0">
+            <a:schemeClr val="dk1"/>
+          </a:fillRef>
+          <a:effectRef idx="1">
+            <a:schemeClr val="dk1"/>
+          </a:effectRef>
+          <a:fontRef idx="minor">
+            <a:schemeClr val="tx1"/>
+          </a:fontRef>
+        </p:style>
+      </p:cxnSp>
     </p:spTree>
     <p:extLst>
       <p:ext uri="{BB962C8B-B14F-4D97-AF65-F5344CB8AC3E}">
-        <p14:creationId xmlns:p14="http://schemas.microsoft.com/office/powerpoint/2010/main" val="1207860193"/>
+        <p14:creationId xmlns:p14="http://schemas.microsoft.com/office/powerpoint/2010/main" val="1876375741"/>
       </p:ext>
     </p:extLst>
   </p:cSld>
@@ -4879,7 +5434,7 @@
 </p:sld>
 </file>
 
-<file path=ppt/slides/slide2.xml><?xml version="1.0" encoding="utf-8"?>
+<file path=ppt/slides/slide3.xml><?xml version="1.0" encoding="utf-8"?>
 <p:sld xmlns:a="http://schemas.openxmlformats.org/drawingml/2006/main" xmlns:r="http://schemas.openxmlformats.org/officeDocument/2006/relationships" xmlns:p="http://schemas.openxmlformats.org/presentationml/2006/main">
   <p:cSld>
     <p:spTree>
@@ -6009,7 +6564,7 @@
 </p:sld>
 </file>
 
-<file path=ppt/slides/slide3.xml><?xml version="1.0" encoding="utf-8"?>
+<file path=ppt/slides/slide4.xml><?xml version="1.0" encoding="utf-8"?>
 <p:sld xmlns:a="http://schemas.openxmlformats.org/drawingml/2006/main" xmlns:r="http://schemas.openxmlformats.org/officeDocument/2006/relationships" xmlns:p="http://schemas.openxmlformats.org/presentationml/2006/main">
   <p:cSld>
     <p:spTree>
@@ -6154,7 +6709,7 @@
 </p:sld>
 </file>
 
-<file path=ppt/slides/slide4.xml><?xml version="1.0" encoding="utf-8"?>
+<file path=ppt/slides/slide5.xml><?xml version="1.0" encoding="utf-8"?>
 <p:sld xmlns:a="http://schemas.openxmlformats.org/drawingml/2006/main" xmlns:r="http://schemas.openxmlformats.org/officeDocument/2006/relationships" xmlns:p="http://schemas.openxmlformats.org/presentationml/2006/main">
   <p:cSld>
     <p:spTree>
@@ -6229,7 +6784,7 @@
         <p:spPr>
           <a:xfrm>
             <a:off x="133349" y="712252"/>
-            <a:ext cx="11877675" cy="1569660"/>
+            <a:ext cx="4834891" cy="1938992"/>
           </a:xfrm>
           <a:prstGeom prst="rect">
             <a:avLst/>
@@ -6345,6 +6900,96 @@
             <a:endParaRPr lang="fr-FR" sz="1200" dirty="0">
               <a:latin typeface="Raleway" pitchFamily="2" charset="0"/>
             </a:endParaRPr>
+          </a:p>
+        </p:txBody>
+      </p:sp>
+      <p:sp>
+        <p:nvSpPr>
+          <p:cNvPr id="3" name="ZoneTexte 2">
+            <a:extLst>
+              <a:ext uri="{FF2B5EF4-FFF2-40B4-BE49-F238E27FC236}">
+                <a16:creationId xmlns:a16="http://schemas.microsoft.com/office/drawing/2014/main" id="{F4F7F7B1-7DE9-97BD-2866-653D419BF6A1}"/>
+              </a:ext>
+            </a:extLst>
+          </p:cNvPr>
+          <p:cNvSpPr txBox="1"/>
+          <p:nvPr/>
+        </p:nvSpPr>
+        <p:spPr>
+          <a:xfrm>
+            <a:off x="4968241" y="103287"/>
+            <a:ext cx="3714750" cy="461665"/>
+          </a:xfrm>
+          <a:prstGeom prst="rect">
+            <a:avLst/>
+          </a:prstGeom>
+          <a:noFill/>
+        </p:spPr>
+        <p:txBody>
+          <a:bodyPr wrap="square" rtlCol="0">
+            <a:spAutoFit/>
+          </a:bodyPr>
+          <a:lstStyle/>
+          <a:p>
+            <a:r>
+              <a:rPr lang="fr-FR" sz="2400" dirty="0">
+                <a:latin typeface="Raleway" pitchFamily="2" charset="0"/>
+              </a:rPr>
+              <a:t>Problème</a:t>
+            </a:r>
+          </a:p>
+        </p:txBody>
+      </p:sp>
+      <p:sp>
+        <p:nvSpPr>
+          <p:cNvPr id="4" name="ZoneTexte 3">
+            <a:extLst>
+              <a:ext uri="{FF2B5EF4-FFF2-40B4-BE49-F238E27FC236}">
+                <a16:creationId xmlns:a16="http://schemas.microsoft.com/office/drawing/2014/main" id="{BD370FBF-820F-5C7E-02C5-9AB3905250C2}"/>
+              </a:ext>
+            </a:extLst>
+          </p:cNvPr>
+          <p:cNvSpPr txBox="1"/>
+          <p:nvPr/>
+        </p:nvSpPr>
+        <p:spPr>
+          <a:xfrm>
+            <a:off x="4968240" y="712252"/>
+            <a:ext cx="4834891" cy="276999"/>
+          </a:xfrm>
+          <a:prstGeom prst="rect">
+            <a:avLst/>
+          </a:prstGeom>
+          <a:noFill/>
+        </p:spPr>
+        <p:txBody>
+          <a:bodyPr wrap="square" rtlCol="0">
+            <a:spAutoFit/>
+          </a:bodyPr>
+          <a:lstStyle/>
+          <a:p>
+            <a:pPr marL="171450" indent="-171450">
+              <a:buFontTx/>
+              <a:buChar char="-"/>
+            </a:pPr>
+            <a:r>
+              <a:rPr lang="fr-FR" sz="1200" dirty="0">
+                <a:latin typeface="Raleway" pitchFamily="2" charset="0"/>
+              </a:rPr>
+              <a:t>Ne fonctionne pas si il manque un </a:t>
+            </a:r>
+            <a:r>
+              <a:rPr lang="fr-FR" sz="1200" dirty="0" err="1">
+                <a:latin typeface="Raleway" pitchFamily="2" charset="0"/>
+              </a:rPr>
+              <a:t>qr</a:t>
+            </a:r>
+            <a:r>
+              <a:rPr lang="fr-FR" sz="1200" dirty="0">
+                <a:latin typeface="Raleway" pitchFamily="2" charset="0"/>
+              </a:rPr>
+              <a:t> code fixe</a:t>
+            </a:r>
           </a:p>
         </p:txBody>
       </p:sp>

</xml_diff>